<commit_message>
UAS lagi (what to submit)
</commit_message>
<xml_diff>
--- a/case_opensky.pptx
+++ b/case_opensky.pptx
@@ -5,7 +5,7 @@
     <p:sldMasterId id="2147483648" r:id="rId1"/>
   </p:sldMasterIdLst>
   <p:notesMasterIdLst>
-    <p:notesMasterId r:id="rId19"/>
+    <p:notesMasterId r:id="rId20"/>
   </p:notesMasterIdLst>
   <p:sldIdLst>
     <p:sldId id="256" r:id="rId4"/>
@@ -23,6 +23,7 @@
     <p:sldId id="268" r:id="rId16"/>
     <p:sldId id="269" r:id="rId17"/>
     <p:sldId id="270" r:id="rId18"/>
+    <p:sldId id="271" r:id="rId19"/>
   </p:sldIdLst>
   <p:sldSz cx="12192000" cy="6858000"/>
   <p:notesSz cx="6858000" cy="9144000"/>
@@ -148,7 +149,7 @@
       </p:grpSpPr>
       <p:sp>
         <p:nvSpPr>
-          <p:cNvPr id="28964283" name="Header Placeholder 1"/>
+          <p:cNvPr id="624478619" name="Header Placeholder 1"/>
           <p:cNvSpPr>
             <a:spLocks noGrp="1"/>
           </p:cNvSpPr>
@@ -182,7 +183,7 @@
       </p:sp>
       <p:sp>
         <p:nvSpPr>
-          <p:cNvPr id="1405226545" name="Date Placeholder 2"/>
+          <p:cNvPr id="1443579255" name="Date Placeholder 2"/>
           <p:cNvSpPr>
             <a:spLocks noGrp="1"/>
           </p:cNvSpPr>
@@ -220,7 +221,7 @@
       </p:sp>
       <p:sp>
         <p:nvSpPr>
-          <p:cNvPr id="2114748312" name="Slide Image Placeholder 3"/>
+          <p:cNvPr id="1262673985" name="Slide Image Placeholder 3"/>
           <p:cNvSpPr>
             <a:spLocks noChangeAspect="1" noGrp="1" noRot="1"/>
           </p:cNvSpPr>
@@ -256,7 +257,7 @@
       </p:sp>
       <p:sp>
         <p:nvSpPr>
-          <p:cNvPr id="600207013" name="Notes Placeholder 4"/>
+          <p:cNvPr id="1680490334" name="Notes Placeholder 4"/>
           <p:cNvSpPr>
             <a:spLocks noGrp="1"/>
           </p:cNvSpPr>
@@ -330,7 +331,7 @@
       </p:sp>
       <p:sp>
         <p:nvSpPr>
-          <p:cNvPr id="1264616977" name="Footer Placeholder 5"/>
+          <p:cNvPr id="1411556977" name="Footer Placeholder 5"/>
           <p:cNvSpPr>
             <a:spLocks noGrp="1"/>
           </p:cNvSpPr>
@@ -364,7 +365,7 @@
       </p:sp>
       <p:sp>
         <p:nvSpPr>
-          <p:cNvPr id="1455149919" name="Slide Number Placeholder 6"/>
+          <p:cNvPr id="342809727" name="Slide Number Placeholder 6"/>
           <p:cNvSpPr>
             <a:spLocks noGrp="1"/>
           </p:cNvSpPr>
@@ -517,7 +518,7 @@
       </p:grpSpPr>
       <p:sp>
         <p:nvSpPr>
-          <p:cNvPr id="926433509" name="Slide Image Placeholder 1"/>
+          <p:cNvPr id="2006528237" name="Slide Image Placeholder 1"/>
           <p:cNvSpPr>
             <a:spLocks noChangeAspect="1" noGrp="1" noRot="1"/>
           </p:cNvSpPr>
@@ -534,7 +535,7 @@
       </p:sp>
       <p:sp>
         <p:nvSpPr>
-          <p:cNvPr id="1696858536" name="Notes Placeholder 2"/>
+          <p:cNvPr id="1423791236" name="Notes Placeholder 2"/>
           <p:cNvSpPr>
             <a:spLocks noGrp="1"/>
           </p:cNvSpPr>
@@ -559,7 +560,7 @@
       </p:sp>
       <p:sp>
         <p:nvSpPr>
-          <p:cNvPr id="1178698125" name="Slide Number Placeholder 3"/>
+          <p:cNvPr id="2002101392" name="Slide Number Placeholder 3"/>
           <p:cNvSpPr>
             <a:spLocks noGrp="1"/>
           </p:cNvSpPr>
@@ -610,7 +611,7 @@
       </p:grpSpPr>
       <p:sp>
         <p:nvSpPr>
-          <p:cNvPr id="1681179045" name="Slide Image Placeholder 1"/>
+          <p:cNvPr id="1159355155" name="Slide Image Placeholder 1"/>
           <p:cNvSpPr>
             <a:spLocks noChangeAspect="1" noGrp="1" noRot="1"/>
           </p:cNvSpPr>
@@ -622,7 +623,7 @@
       </p:sp>
       <p:sp>
         <p:nvSpPr>
-          <p:cNvPr id="1944208303" name="Notes Placeholder 2"/>
+          <p:cNvPr id="253508610" name="Notes Placeholder 2"/>
           <p:cNvSpPr>
             <a:spLocks noGrp="1"/>
           </p:cNvSpPr>
@@ -644,7 +645,7 @@
       </p:sp>
       <p:sp>
         <p:nvSpPr>
-          <p:cNvPr id="1943153729" name="Slide Number Placeholder 3"/>
+          <p:cNvPr id="545250291" name="Slide Number Placeholder 3"/>
           <p:cNvSpPr>
             <a:spLocks noGrp="1"/>
           </p:cNvSpPr>
@@ -695,7 +696,7 @@
       </p:grpSpPr>
       <p:sp>
         <p:nvSpPr>
-          <p:cNvPr id="844846517" name="Slide Image Placeholder 1"/>
+          <p:cNvPr id="1304614498" name="Slide Image Placeholder 1"/>
           <p:cNvSpPr>
             <a:spLocks noChangeAspect="1" noGrp="1" noRot="1"/>
           </p:cNvSpPr>
@@ -707,7 +708,7 @@
       </p:sp>
       <p:sp>
         <p:nvSpPr>
-          <p:cNvPr id="354761615" name="Notes Placeholder 2"/>
+          <p:cNvPr id="307245512" name="Notes Placeholder 2"/>
           <p:cNvSpPr>
             <a:spLocks noGrp="1"/>
           </p:cNvSpPr>
@@ -729,7 +730,7 @@
       </p:sp>
       <p:sp>
         <p:nvSpPr>
-          <p:cNvPr id="351526851" name="Slide Number Placeholder 3"/>
+          <p:cNvPr id="506380689" name="Slide Number Placeholder 3"/>
           <p:cNvSpPr>
             <a:spLocks noGrp="1"/>
           </p:cNvSpPr>
@@ -780,7 +781,7 @@
       </p:grpSpPr>
       <p:sp>
         <p:nvSpPr>
-          <p:cNvPr id="674445699" name="Slide Image Placeholder 1"/>
+          <p:cNvPr id="780719771" name="Slide Image Placeholder 1"/>
           <p:cNvSpPr>
             <a:spLocks noChangeAspect="1" noGrp="1" noRot="1"/>
           </p:cNvSpPr>
@@ -792,7 +793,7 @@
       </p:sp>
       <p:sp>
         <p:nvSpPr>
-          <p:cNvPr id="1319089817" name="Notes Placeholder 2"/>
+          <p:cNvPr id="1254821761" name="Notes Placeholder 2"/>
           <p:cNvSpPr>
             <a:spLocks noGrp="1"/>
           </p:cNvSpPr>
@@ -814,7 +815,7 @@
       </p:sp>
       <p:sp>
         <p:nvSpPr>
-          <p:cNvPr id="501990404" name="Slide Number Placeholder 3"/>
+          <p:cNvPr id="2054891712" name="Slide Number Placeholder 3"/>
           <p:cNvSpPr>
             <a:spLocks noGrp="1"/>
           </p:cNvSpPr>
@@ -865,7 +866,7 @@
       </p:grpSpPr>
       <p:sp>
         <p:nvSpPr>
-          <p:cNvPr id="1959218606" name="Slide Image Placeholder 1"/>
+          <p:cNvPr id="188451027" name="Slide Image Placeholder 1"/>
           <p:cNvSpPr>
             <a:spLocks noChangeAspect="1" noGrp="1" noRot="1"/>
           </p:cNvSpPr>
@@ -877,7 +878,7 @@
       </p:sp>
       <p:sp>
         <p:nvSpPr>
-          <p:cNvPr id="704519359" name="Notes Placeholder 2"/>
+          <p:cNvPr id="1424961916" name="Notes Placeholder 2"/>
           <p:cNvSpPr>
             <a:spLocks noGrp="1"/>
           </p:cNvSpPr>
@@ -899,7 +900,7 @@
       </p:sp>
       <p:sp>
         <p:nvSpPr>
-          <p:cNvPr id="633660823" name="Slide Number Placeholder 3"/>
+          <p:cNvPr id="961209690" name="Slide Number Placeholder 3"/>
           <p:cNvSpPr>
             <a:spLocks noGrp="1"/>
           </p:cNvSpPr>
@@ -950,7 +951,7 @@
       </p:grpSpPr>
       <p:sp>
         <p:nvSpPr>
-          <p:cNvPr id="1785290100" name="Slide Image Placeholder 1"/>
+          <p:cNvPr id="409184094" name="Slide Image Placeholder 1"/>
           <p:cNvSpPr>
             <a:spLocks noChangeAspect="1" noGrp="1" noRot="1"/>
           </p:cNvSpPr>
@@ -962,7 +963,7 @@
       </p:sp>
       <p:sp>
         <p:nvSpPr>
-          <p:cNvPr id="992155978" name="Notes Placeholder 2"/>
+          <p:cNvPr id="2142102959" name="Notes Placeholder 2"/>
           <p:cNvSpPr>
             <a:spLocks noGrp="1"/>
           </p:cNvSpPr>
@@ -984,7 +985,7 @@
       </p:sp>
       <p:sp>
         <p:nvSpPr>
-          <p:cNvPr id="993095310" name="Slide Number Placeholder 3"/>
+          <p:cNvPr id="519135506" name="Slide Number Placeholder 3"/>
           <p:cNvSpPr>
             <a:spLocks noGrp="1"/>
           </p:cNvSpPr>
@@ -1035,7 +1036,7 @@
       </p:grpSpPr>
       <p:sp>
         <p:nvSpPr>
-          <p:cNvPr id="1115427970" name="Slide Image Placeholder 1"/>
+          <p:cNvPr id="596002818" name="Slide Image Placeholder 1"/>
           <p:cNvSpPr>
             <a:spLocks noChangeAspect="1" noGrp="1" noRot="1"/>
           </p:cNvSpPr>
@@ -1047,7 +1048,7 @@
       </p:sp>
       <p:sp>
         <p:nvSpPr>
-          <p:cNvPr id="194919107" name="Notes Placeholder 2"/>
+          <p:cNvPr id="2024872573" name="Notes Placeholder 2"/>
           <p:cNvSpPr>
             <a:spLocks noGrp="1"/>
           </p:cNvSpPr>
@@ -1069,7 +1070,7 @@
       </p:sp>
       <p:sp>
         <p:nvSpPr>
-          <p:cNvPr id="376558902" name="Slide Number Placeholder 3"/>
+          <p:cNvPr id="1530185929" name="Slide Number Placeholder 3"/>
           <p:cNvSpPr>
             <a:spLocks noGrp="1"/>
           </p:cNvSpPr>
@@ -1086,6 +1087,91 @@
               <a:defRPr/>
             </a:pPr>
             <a:fld id="{D7545BDC-7D65-F0D8-C64B-91B09568DB32}" type="slidenum">
+              <a:rPr/>
+              <a:t/>
+            </a:fld>
+            <a:endParaRPr/>
+          </a:p>
+        </p:txBody>
+      </p:sp>
+    </p:spTree>
+  </p:cSld>
+  <p:clrMapOvr>
+    <a:masterClrMapping/>
+  </p:clrMapOvr>
+</p:notes>
+</file>
+
+<file path=ppt/notesSlides/notesSlide16.xml><?xml version="1.0" encoding="utf-8"?>
+<p:notes xmlns:a="http://schemas.openxmlformats.org/drawingml/2006/main" xmlns:r="http://schemas.openxmlformats.org/officeDocument/2006/relationships" xmlns:p="http://schemas.openxmlformats.org/presentationml/2006/main" xmlns:m="http://schemas.openxmlformats.org/officeDocument/2006/math" xmlns:w="http://schemas.openxmlformats.org/wordprocessingml/2006/main">
+  <p:cSld name="">
+    <p:spTree>
+      <p:nvGrpSpPr>
+        <p:cNvPr id="1" name=""/>
+        <p:cNvGrpSpPr/>
+        <p:nvPr/>
+      </p:nvGrpSpPr>
+      <p:grpSpPr bwMode="auto">
+        <a:xfrm>
+          <a:off x="0" y="0"/>
+          <a:ext cx="0" cy="0"/>
+          <a:chOff x="0" y="0"/>
+          <a:chExt cx="0" cy="0"/>
+        </a:xfrm>
+      </p:grpSpPr>
+      <p:sp>
+        <p:nvSpPr>
+          <p:cNvPr id="622575018" name="Slide Image Placeholder 1"/>
+          <p:cNvSpPr>
+            <a:spLocks noChangeAspect="1" noGrp="1" noRot="1"/>
+          </p:cNvSpPr>
+          <p:nvPr>
+            <p:ph type="sldImg"/>
+          </p:nvPr>
+        </p:nvSpPr>
+        <p:spPr bwMode="auto"/>
+      </p:sp>
+      <p:sp>
+        <p:nvSpPr>
+          <p:cNvPr id="1657828915" name="Notes Placeholder 2"/>
+          <p:cNvSpPr>
+            <a:spLocks noGrp="1"/>
+          </p:cNvSpPr>
+          <p:nvPr>
+            <p:ph type="body" idx="1"/>
+          </p:nvPr>
+        </p:nvSpPr>
+        <p:spPr bwMode="auto"/>
+        <p:txBody>
+          <a:bodyPr/>
+          <a:lstStyle/>
+          <a:p>
+            <a:pPr>
+              <a:defRPr/>
+            </a:pPr>
+            <a:endParaRPr/>
+          </a:p>
+        </p:txBody>
+      </p:sp>
+      <p:sp>
+        <p:nvSpPr>
+          <p:cNvPr id="1945263286" name="Slide Number Placeholder 3"/>
+          <p:cNvSpPr>
+            <a:spLocks noGrp="1"/>
+          </p:cNvSpPr>
+          <p:nvPr>
+            <p:ph type="sldNum" sz="quarter" idx="10"/>
+          </p:nvPr>
+        </p:nvSpPr>
+        <p:spPr bwMode="auto"/>
+        <p:txBody>
+          <a:bodyPr/>
+          <a:lstStyle/>
+          <a:p>
+            <a:pPr>
+              <a:defRPr/>
+            </a:pPr>
+            <a:fld id="{48BD9083-53FA-A808-5B35-B6B77935A12B}" type="slidenum">
               <a:rPr/>
               <a:t/>
             </a:fld>
@@ -1120,7 +1206,7 @@
       </p:grpSpPr>
       <p:sp>
         <p:nvSpPr>
-          <p:cNvPr id="514945911" name="Slide Image Placeholder 1"/>
+          <p:cNvPr id="1358332329" name="Slide Image Placeholder 1"/>
           <p:cNvSpPr>
             <a:spLocks noChangeAspect="1" noGrp="1" noRot="1"/>
           </p:cNvSpPr>
@@ -1137,7 +1223,7 @@
       </p:sp>
       <p:sp>
         <p:nvSpPr>
-          <p:cNvPr id="1533036714" name="Notes Placeholder 2"/>
+          <p:cNvPr id="446376343" name="Notes Placeholder 2"/>
           <p:cNvSpPr>
             <a:spLocks noGrp="1"/>
           </p:cNvSpPr>
@@ -1162,7 +1248,7 @@
       </p:sp>
       <p:sp>
         <p:nvSpPr>
-          <p:cNvPr id="2083996233" name="Slide Number Placeholder 3"/>
+          <p:cNvPr id="1426461204" name="Slide Number Placeholder 3"/>
           <p:cNvSpPr>
             <a:spLocks noGrp="1"/>
           </p:cNvSpPr>
@@ -1213,7 +1299,7 @@
       </p:grpSpPr>
       <p:sp>
         <p:nvSpPr>
-          <p:cNvPr id="411520691" name="Slide Image Placeholder 1"/>
+          <p:cNvPr id="1351331728" name="Slide Image Placeholder 1"/>
           <p:cNvSpPr>
             <a:spLocks noChangeAspect="1" noGrp="1" noRot="1"/>
           </p:cNvSpPr>
@@ -1225,7 +1311,7 @@
       </p:sp>
       <p:sp>
         <p:nvSpPr>
-          <p:cNvPr id="267192955" name="Notes Placeholder 2"/>
+          <p:cNvPr id="2014956617" name="Notes Placeholder 2"/>
           <p:cNvSpPr>
             <a:spLocks noGrp="1"/>
           </p:cNvSpPr>
@@ -1247,7 +1333,7 @@
       </p:sp>
       <p:sp>
         <p:nvSpPr>
-          <p:cNvPr id="1638363417" name="Slide Number Placeholder 3"/>
+          <p:cNvPr id="1840607544" name="Slide Number Placeholder 3"/>
           <p:cNvSpPr>
             <a:spLocks noGrp="1"/>
           </p:cNvSpPr>
@@ -1298,7 +1384,7 @@
       </p:grpSpPr>
       <p:sp>
         <p:nvSpPr>
-          <p:cNvPr id="750344616" name="Slide Image Placeholder 1"/>
+          <p:cNvPr id="133949847" name="Slide Image Placeholder 1"/>
           <p:cNvSpPr>
             <a:spLocks noChangeAspect="1" noGrp="1" noRot="1"/>
           </p:cNvSpPr>
@@ -1310,7 +1396,7 @@
       </p:sp>
       <p:sp>
         <p:nvSpPr>
-          <p:cNvPr id="256705100" name="Notes Placeholder 2"/>
+          <p:cNvPr id="222619339" name="Notes Placeholder 2"/>
           <p:cNvSpPr>
             <a:spLocks noGrp="1"/>
           </p:cNvSpPr>
@@ -1332,7 +1418,7 @@
       </p:sp>
       <p:sp>
         <p:nvSpPr>
-          <p:cNvPr id="1190357709" name="Slide Number Placeholder 3"/>
+          <p:cNvPr id="713240764" name="Slide Number Placeholder 3"/>
           <p:cNvSpPr>
             <a:spLocks noGrp="1"/>
           </p:cNvSpPr>
@@ -1383,7 +1469,7 @@
       </p:grpSpPr>
       <p:sp>
         <p:nvSpPr>
-          <p:cNvPr id="1835205983" name="Slide Image Placeholder 1"/>
+          <p:cNvPr id="1195087294" name="Slide Image Placeholder 1"/>
           <p:cNvSpPr>
             <a:spLocks noChangeAspect="1" noGrp="1" noRot="1"/>
           </p:cNvSpPr>
@@ -1395,7 +1481,7 @@
       </p:sp>
       <p:sp>
         <p:nvSpPr>
-          <p:cNvPr id="1601243042" name="Notes Placeholder 2"/>
+          <p:cNvPr id="1990014078" name="Notes Placeholder 2"/>
           <p:cNvSpPr>
             <a:spLocks noGrp="1"/>
           </p:cNvSpPr>
@@ -1417,7 +1503,7 @@
       </p:sp>
       <p:sp>
         <p:nvSpPr>
-          <p:cNvPr id="1506905031" name="Slide Number Placeholder 3"/>
+          <p:cNvPr id="1621884808" name="Slide Number Placeholder 3"/>
           <p:cNvSpPr>
             <a:spLocks noGrp="1"/>
           </p:cNvSpPr>
@@ -1468,7 +1554,7 @@
       </p:grpSpPr>
       <p:sp>
         <p:nvSpPr>
-          <p:cNvPr id="1061060860" name="Slide Image Placeholder 1"/>
+          <p:cNvPr id="589379710" name="Slide Image Placeholder 1"/>
           <p:cNvSpPr>
             <a:spLocks noChangeAspect="1" noGrp="1" noRot="1"/>
           </p:cNvSpPr>
@@ -1480,7 +1566,7 @@
       </p:sp>
       <p:sp>
         <p:nvSpPr>
-          <p:cNvPr id="6148638" name="Notes Placeholder 2"/>
+          <p:cNvPr id="737301570" name="Notes Placeholder 2"/>
           <p:cNvSpPr>
             <a:spLocks noGrp="1"/>
           </p:cNvSpPr>
@@ -1502,7 +1588,7 @@
       </p:sp>
       <p:sp>
         <p:nvSpPr>
-          <p:cNvPr id="1467718444" name="Slide Number Placeholder 3"/>
+          <p:cNvPr id="1019366633" name="Slide Number Placeholder 3"/>
           <p:cNvSpPr>
             <a:spLocks noGrp="1"/>
           </p:cNvSpPr>
@@ -1553,7 +1639,7 @@
       </p:grpSpPr>
       <p:sp>
         <p:nvSpPr>
-          <p:cNvPr id="2006798577" name="Slide Image Placeholder 1"/>
+          <p:cNvPr id="1102368649" name="Slide Image Placeholder 1"/>
           <p:cNvSpPr>
             <a:spLocks noChangeAspect="1" noGrp="1" noRot="1"/>
           </p:cNvSpPr>
@@ -1565,7 +1651,7 @@
       </p:sp>
       <p:sp>
         <p:nvSpPr>
-          <p:cNvPr id="1209502243" name="Notes Placeholder 2"/>
+          <p:cNvPr id="832772650" name="Notes Placeholder 2"/>
           <p:cNvSpPr>
             <a:spLocks noGrp="1"/>
           </p:cNvSpPr>
@@ -1587,7 +1673,7 @@
       </p:sp>
       <p:sp>
         <p:nvSpPr>
-          <p:cNvPr id="77829197" name="Slide Number Placeholder 3"/>
+          <p:cNvPr id="1270257943" name="Slide Number Placeholder 3"/>
           <p:cNvSpPr>
             <a:spLocks noGrp="1"/>
           </p:cNvSpPr>
@@ -1638,7 +1724,7 @@
       </p:grpSpPr>
       <p:sp>
         <p:nvSpPr>
-          <p:cNvPr id="39350323" name="Slide Image Placeholder 1"/>
+          <p:cNvPr id="700169060" name="Slide Image Placeholder 1"/>
           <p:cNvSpPr>
             <a:spLocks noChangeAspect="1" noGrp="1" noRot="1"/>
           </p:cNvSpPr>
@@ -1650,7 +1736,7 @@
       </p:sp>
       <p:sp>
         <p:nvSpPr>
-          <p:cNvPr id="83752436" name="Notes Placeholder 2"/>
+          <p:cNvPr id="401940278" name="Notes Placeholder 2"/>
           <p:cNvSpPr>
             <a:spLocks noGrp="1"/>
           </p:cNvSpPr>
@@ -1672,7 +1758,7 @@
       </p:sp>
       <p:sp>
         <p:nvSpPr>
-          <p:cNvPr id="81478191" name="Slide Number Placeholder 3"/>
+          <p:cNvPr id="864729780" name="Slide Number Placeholder 3"/>
           <p:cNvSpPr>
             <a:spLocks noGrp="1"/>
           </p:cNvSpPr>
@@ -1723,7 +1809,7 @@
       </p:grpSpPr>
       <p:sp>
         <p:nvSpPr>
-          <p:cNvPr id="87901688" name="Slide Image Placeholder 1"/>
+          <p:cNvPr id="1526047138" name="Slide Image Placeholder 1"/>
           <p:cNvSpPr>
             <a:spLocks noChangeAspect="1" noGrp="1" noRot="1"/>
           </p:cNvSpPr>
@@ -1735,7 +1821,7 @@
       </p:sp>
       <p:sp>
         <p:nvSpPr>
-          <p:cNvPr id="576877012" name="Notes Placeholder 2"/>
+          <p:cNvPr id="1914248324" name="Notes Placeholder 2"/>
           <p:cNvSpPr>
             <a:spLocks noGrp="1"/>
           </p:cNvSpPr>
@@ -1757,7 +1843,7 @@
       </p:sp>
       <p:sp>
         <p:nvSpPr>
-          <p:cNvPr id="1994932305" name="Slide Number Placeholder 3"/>
+          <p:cNvPr id="76032551" name="Slide Number Placeholder 3"/>
           <p:cNvSpPr>
             <a:spLocks noGrp="1"/>
           </p:cNvSpPr>
@@ -1808,7 +1894,7 @@
       </p:grpSpPr>
       <p:sp>
         <p:nvSpPr>
-          <p:cNvPr id="1699816192" name="Shape 1059"/>
+          <p:cNvPr id="784524175" name="Shape 1059"/>
           <p:cNvSpPr>
             <a:spLocks noChangeArrowheads="1" noGrp="1"/>
           </p:cNvSpPr>
@@ -1931,7 +2017,7 @@
       </p:sp>
       <p:sp>
         <p:nvSpPr>
-          <p:cNvPr id="86338412" name="Shape 1060"/>
+          <p:cNvPr id="2059265795" name="Shape 1060"/>
           <p:cNvSpPr>
             <a:spLocks noChangeArrowheads="1" noGrp="1"/>
           </p:cNvSpPr>
@@ -2022,7 +2108,7 @@
       </p:sp>
       <p:sp>
         <p:nvSpPr>
-          <p:cNvPr id="594990131" name="Shape 1061"/>
+          <p:cNvPr id="2052240529" name="Shape 1061"/>
           <p:cNvSpPr>
             <a:spLocks noChangeArrowheads="1" noGrp="1"/>
           </p:cNvSpPr>
@@ -2108,7 +2194,7 @@
       </p:sp>
       <p:sp>
         <p:nvSpPr>
-          <p:cNvPr id="1673837773" name="Shape 1062"/>
+          <p:cNvPr id="1507814082" name="Shape 1062"/>
           <p:cNvSpPr>
             <a:spLocks noChangeArrowheads="1" noGrp="1"/>
           </p:cNvSpPr>
@@ -2186,7 +2272,7 @@
       </p:sp>
       <p:sp>
         <p:nvSpPr>
-          <p:cNvPr id="1434060295" name="Shape 1063"/>
+          <p:cNvPr id="436287371" name="Shape 1063"/>
           <p:cNvSpPr>
             <a:spLocks noChangeArrowheads="1" noGrp="1"/>
           </p:cNvSpPr>
@@ -2264,7 +2350,7 @@
       </p:sp>
       <p:sp>
         <p:nvSpPr>
-          <p:cNvPr id="1137961041" name="Subtitle 2"/>
+          <p:cNvPr id="1734411719" name="Subtitle 2"/>
           <p:cNvSpPr>
             <a:spLocks noGrp="1"/>
           </p:cNvSpPr>
@@ -2387,7 +2473,7 @@
       </p:sp>
       <p:sp>
         <p:nvSpPr>
-          <p:cNvPr id="986704736" name="Date Placeholder 3"/>
+          <p:cNvPr id="1434745968" name="Date Placeholder 3"/>
           <p:cNvSpPr>
             <a:spLocks noGrp="1"/>
           </p:cNvSpPr>
@@ -2413,7 +2499,7 @@
       </p:sp>
       <p:sp>
         <p:nvSpPr>
-          <p:cNvPr id="1898492456" name="Footer Placeholder 4"/>
+          <p:cNvPr id="1807994377" name="Footer Placeholder 4"/>
           <p:cNvSpPr>
             <a:spLocks noGrp="1"/>
           </p:cNvSpPr>
@@ -2435,7 +2521,7 @@
       </p:sp>
       <p:sp>
         <p:nvSpPr>
-          <p:cNvPr id="1929570294" name="Slide Number Placeholder 5"/>
+          <p:cNvPr id="2040491765" name="Slide Number Placeholder 5"/>
           <p:cNvSpPr>
             <a:spLocks noGrp="1"/>
           </p:cNvSpPr>
@@ -2461,7 +2547,7 @@
       </p:sp>
       <p:sp>
         <p:nvSpPr>
-          <p:cNvPr id="1420012467" name="Title 6"/>
+          <p:cNvPr id="1023727441" name="Title 6"/>
           <p:cNvSpPr>
             <a:spLocks noGrp="1"/>
           </p:cNvSpPr>
@@ -2521,7 +2607,7 @@
       </p:grpSpPr>
       <p:sp>
         <p:nvSpPr>
-          <p:cNvPr id="1493207914" name="Title 1"/>
+          <p:cNvPr id="1458044748" name="Title 1"/>
           <p:cNvSpPr>
             <a:spLocks noGrp="1"/>
           </p:cNvSpPr>
@@ -2547,7 +2633,7 @@
       </p:sp>
       <p:sp>
         <p:nvSpPr>
-          <p:cNvPr id="1050350323" name="Vertical Text Placeholder 2"/>
+          <p:cNvPr id="817878991" name="Vertical Text Placeholder 2"/>
           <p:cNvSpPr>
             <a:spLocks noGrp="1"/>
           </p:cNvSpPr>
@@ -2613,7 +2699,7 @@
       </p:sp>
       <p:sp>
         <p:nvSpPr>
-          <p:cNvPr id="1245563872" name="Date Placeholder 3"/>
+          <p:cNvPr id="256364760" name="Date Placeholder 3"/>
           <p:cNvSpPr>
             <a:spLocks noGrp="1"/>
           </p:cNvSpPr>
@@ -2639,7 +2725,7 @@
       </p:sp>
       <p:sp>
         <p:nvSpPr>
-          <p:cNvPr id="659430657" name="Footer Placeholder 4"/>
+          <p:cNvPr id="1662987950" name="Footer Placeholder 4"/>
           <p:cNvSpPr>
             <a:spLocks noGrp="1"/>
           </p:cNvSpPr>
@@ -2661,7 +2747,7 @@
       </p:sp>
       <p:sp>
         <p:nvSpPr>
-          <p:cNvPr id="1963770297" name="Slide Number Placeholder 5"/>
+          <p:cNvPr id="79211086" name="Slide Number Placeholder 5"/>
           <p:cNvSpPr>
             <a:spLocks noGrp="1"/>
           </p:cNvSpPr>
@@ -2712,7 +2798,7 @@
       </p:grpSpPr>
       <p:sp>
         <p:nvSpPr>
-          <p:cNvPr id="1160193190" name="Vertical Title 1"/>
+          <p:cNvPr id="1876808672" name="Vertical Title 1"/>
           <p:cNvSpPr>
             <a:spLocks noGrp="1"/>
           </p:cNvSpPr>
@@ -2747,7 +2833,7 @@
       </p:sp>
       <p:sp>
         <p:nvSpPr>
-          <p:cNvPr id="59542929" name="Vertical Text Placeholder 2"/>
+          <p:cNvPr id="445422803" name="Vertical Text Placeholder 2"/>
           <p:cNvSpPr>
             <a:spLocks noGrp="1"/>
           </p:cNvSpPr>
@@ -2818,7 +2904,7 @@
       </p:sp>
       <p:sp>
         <p:nvSpPr>
-          <p:cNvPr id="465385579" name="Date Placeholder 3"/>
+          <p:cNvPr id="1826924272" name="Date Placeholder 3"/>
           <p:cNvSpPr>
             <a:spLocks noGrp="1"/>
           </p:cNvSpPr>
@@ -2844,7 +2930,7 @@
       </p:sp>
       <p:sp>
         <p:nvSpPr>
-          <p:cNvPr id="962863805" name="Footer Placeholder 4"/>
+          <p:cNvPr id="2003012752" name="Footer Placeholder 4"/>
           <p:cNvSpPr>
             <a:spLocks noGrp="1"/>
           </p:cNvSpPr>
@@ -2866,7 +2952,7 @@
       </p:sp>
       <p:sp>
         <p:nvSpPr>
-          <p:cNvPr id="240334656" name="Slide Number Placeholder 5"/>
+          <p:cNvPr id="1170208905" name="Slide Number Placeholder 5"/>
           <p:cNvSpPr>
             <a:spLocks noGrp="1"/>
           </p:cNvSpPr>
@@ -2917,7 +3003,7 @@
       </p:grpSpPr>
       <p:sp>
         <p:nvSpPr>
-          <p:cNvPr id="585425050" name="Title 1"/>
+          <p:cNvPr id="221153924" name="Title 1"/>
           <p:cNvSpPr>
             <a:spLocks noGrp="1"/>
           </p:cNvSpPr>
@@ -2943,7 +3029,7 @@
       </p:sp>
       <p:sp>
         <p:nvSpPr>
-          <p:cNvPr id="394325239" name="Content Placeholder 2"/>
+          <p:cNvPr id="748845021" name="Content Placeholder 2"/>
           <p:cNvSpPr>
             <a:spLocks noGrp="1"/>
           </p:cNvSpPr>
@@ -3009,7 +3095,7 @@
       </p:sp>
       <p:sp>
         <p:nvSpPr>
-          <p:cNvPr id="1534301988" name="Date Placeholder 3"/>
+          <p:cNvPr id="960527207" name="Date Placeholder 3"/>
           <p:cNvSpPr>
             <a:spLocks noGrp="1"/>
           </p:cNvSpPr>
@@ -3035,7 +3121,7 @@
       </p:sp>
       <p:sp>
         <p:nvSpPr>
-          <p:cNvPr id="1886880331" name="Footer Placeholder 4"/>
+          <p:cNvPr id="2007176898" name="Footer Placeholder 4"/>
           <p:cNvSpPr>
             <a:spLocks noGrp="1"/>
           </p:cNvSpPr>
@@ -3057,7 +3143,7 @@
       </p:sp>
       <p:sp>
         <p:nvSpPr>
-          <p:cNvPr id="1085741429" name="Slide Number Placeholder 5"/>
+          <p:cNvPr id="2092461594" name="Slide Number Placeholder 5"/>
           <p:cNvSpPr>
             <a:spLocks noGrp="1"/>
           </p:cNvSpPr>
@@ -3108,7 +3194,7 @@
       </p:grpSpPr>
       <p:sp>
         <p:nvSpPr>
-          <p:cNvPr id="415300345" name="Title 1"/>
+          <p:cNvPr id="1520429779" name="Title 1"/>
           <p:cNvSpPr>
             <a:spLocks noGrp="1"/>
           </p:cNvSpPr>
@@ -3143,7 +3229,7 @@
       </p:sp>
       <p:sp>
         <p:nvSpPr>
-          <p:cNvPr id="267911315" name="Text Placeholder 2"/>
+          <p:cNvPr id="422313744" name="Text Placeholder 2"/>
           <p:cNvSpPr>
             <a:spLocks noGrp="1"/>
           </p:cNvSpPr>
@@ -3265,7 +3351,7 @@
       </p:sp>
       <p:sp>
         <p:nvSpPr>
-          <p:cNvPr id="1640020472" name="Date Placeholder 3"/>
+          <p:cNvPr id="131003381" name="Date Placeholder 3"/>
           <p:cNvSpPr>
             <a:spLocks noGrp="1"/>
           </p:cNvSpPr>
@@ -3291,7 +3377,7 @@
       </p:sp>
       <p:sp>
         <p:nvSpPr>
-          <p:cNvPr id="710258638" name="Footer Placeholder 4"/>
+          <p:cNvPr id="1259242858" name="Footer Placeholder 4"/>
           <p:cNvSpPr>
             <a:spLocks noGrp="1"/>
           </p:cNvSpPr>
@@ -3313,7 +3399,7 @@
       </p:sp>
       <p:sp>
         <p:nvSpPr>
-          <p:cNvPr id="1278556185" name="Slide Number Placeholder 5"/>
+          <p:cNvPr id="481980662" name="Slide Number Placeholder 5"/>
           <p:cNvSpPr>
             <a:spLocks noGrp="1"/>
           </p:cNvSpPr>
@@ -3364,7 +3450,7 @@
       </p:grpSpPr>
       <p:sp>
         <p:nvSpPr>
-          <p:cNvPr id="379120589" name="Title 1"/>
+          <p:cNvPr id="2046371738" name="Title 1"/>
           <p:cNvSpPr>
             <a:spLocks noGrp="1"/>
           </p:cNvSpPr>
@@ -3390,7 +3476,7 @@
       </p:sp>
       <p:sp>
         <p:nvSpPr>
-          <p:cNvPr id="502748651" name="Content Placeholder 2"/>
+          <p:cNvPr id="803668597" name="Content Placeholder 2"/>
           <p:cNvSpPr>
             <a:spLocks noGrp="1"/>
           </p:cNvSpPr>
@@ -3489,7 +3575,7 @@
       </p:sp>
       <p:sp>
         <p:nvSpPr>
-          <p:cNvPr id="1649492305" name="Content Placeholder 3"/>
+          <p:cNvPr id="516779848" name="Content Placeholder 3"/>
           <p:cNvSpPr>
             <a:spLocks noGrp="1"/>
           </p:cNvSpPr>
@@ -3588,7 +3674,7 @@
       </p:sp>
       <p:sp>
         <p:nvSpPr>
-          <p:cNvPr id="406512181" name="Date Placeholder 4"/>
+          <p:cNvPr id="1909953995" name="Date Placeholder 4"/>
           <p:cNvSpPr>
             <a:spLocks noGrp="1"/>
           </p:cNvSpPr>
@@ -3614,7 +3700,7 @@
       </p:sp>
       <p:sp>
         <p:nvSpPr>
-          <p:cNvPr id="160841553" name="Footer Placeholder 5"/>
+          <p:cNvPr id="1240571630" name="Footer Placeholder 5"/>
           <p:cNvSpPr>
             <a:spLocks noGrp="1"/>
           </p:cNvSpPr>
@@ -3636,7 +3722,7 @@
       </p:sp>
       <p:sp>
         <p:nvSpPr>
-          <p:cNvPr id="1124474217" name="Slide Number Placeholder 6"/>
+          <p:cNvPr id="353312984" name="Slide Number Placeholder 6"/>
           <p:cNvSpPr>
             <a:spLocks noGrp="1"/>
           </p:cNvSpPr>
@@ -3687,7 +3773,7 @@
       </p:grpSpPr>
       <p:sp>
         <p:nvSpPr>
-          <p:cNvPr id="104877283" name="Title 1"/>
+          <p:cNvPr id="1018744267" name="Title 1"/>
           <p:cNvSpPr>
             <a:spLocks noGrp="1"/>
           </p:cNvSpPr>
@@ -3717,7 +3803,7 @@
       </p:sp>
       <p:sp>
         <p:nvSpPr>
-          <p:cNvPr id="1977415570" name="Text Placeholder 2"/>
+          <p:cNvPr id="1284551062" name="Text Placeholder 2"/>
           <p:cNvSpPr>
             <a:spLocks noGrp="1"/>
           </p:cNvSpPr>
@@ -3785,7 +3871,7 @@
       </p:sp>
       <p:sp>
         <p:nvSpPr>
-          <p:cNvPr id="510847930" name="Content Placeholder 3"/>
+          <p:cNvPr id="520353076" name="Content Placeholder 3"/>
           <p:cNvSpPr>
             <a:spLocks noGrp="1"/>
           </p:cNvSpPr>
@@ -3884,7 +3970,7 @@
       </p:sp>
       <p:sp>
         <p:nvSpPr>
-          <p:cNvPr id="1745655063" name="Text Placeholder 4"/>
+          <p:cNvPr id="1637356248" name="Text Placeholder 4"/>
           <p:cNvSpPr>
             <a:spLocks noGrp="1"/>
           </p:cNvSpPr>
@@ -3952,7 +4038,7 @@
       </p:sp>
       <p:sp>
         <p:nvSpPr>
-          <p:cNvPr id="672925014" name="Content Placeholder 5"/>
+          <p:cNvPr id="1748757816" name="Content Placeholder 5"/>
           <p:cNvSpPr>
             <a:spLocks noGrp="1"/>
           </p:cNvSpPr>
@@ -4051,7 +4137,7 @@
       </p:sp>
       <p:sp>
         <p:nvSpPr>
-          <p:cNvPr id="1577936930" name="Date Placeholder 6"/>
+          <p:cNvPr id="1343819638" name="Date Placeholder 6"/>
           <p:cNvSpPr>
             <a:spLocks noGrp="1"/>
           </p:cNvSpPr>
@@ -4077,7 +4163,7 @@
       </p:sp>
       <p:sp>
         <p:nvSpPr>
-          <p:cNvPr id="1964162382" name="Footer Placeholder 7"/>
+          <p:cNvPr id="1786518875" name="Footer Placeholder 7"/>
           <p:cNvSpPr>
             <a:spLocks noGrp="1"/>
           </p:cNvSpPr>
@@ -4099,7 +4185,7 @@
       </p:sp>
       <p:sp>
         <p:nvSpPr>
-          <p:cNvPr id="93296419" name="Slide Number Placeholder 8"/>
+          <p:cNvPr id="551898293" name="Slide Number Placeholder 8"/>
           <p:cNvSpPr>
             <a:spLocks noGrp="1"/>
           </p:cNvSpPr>
@@ -4150,7 +4236,7 @@
       </p:grpSpPr>
       <p:sp>
         <p:nvSpPr>
-          <p:cNvPr id="729367662" name="Title 1"/>
+          <p:cNvPr id="1130793295" name="Title 1"/>
           <p:cNvSpPr>
             <a:spLocks noGrp="1"/>
           </p:cNvSpPr>
@@ -4176,7 +4262,7 @@
       </p:sp>
       <p:sp>
         <p:nvSpPr>
-          <p:cNvPr id="1218615062" name="Date Placeholder 2"/>
+          <p:cNvPr id="1186911572" name="Date Placeholder 2"/>
           <p:cNvSpPr>
             <a:spLocks noGrp="1"/>
           </p:cNvSpPr>
@@ -4202,7 +4288,7 @@
       </p:sp>
       <p:sp>
         <p:nvSpPr>
-          <p:cNvPr id="1703357559" name="Footer Placeholder 3"/>
+          <p:cNvPr id="1804801611" name="Footer Placeholder 3"/>
           <p:cNvSpPr>
             <a:spLocks noGrp="1"/>
           </p:cNvSpPr>
@@ -4224,7 +4310,7 @@
       </p:sp>
       <p:sp>
         <p:nvSpPr>
-          <p:cNvPr id="720914594" name="Slide Number Placeholder 4"/>
+          <p:cNvPr id="1635405075" name="Slide Number Placeholder 4"/>
           <p:cNvSpPr>
             <a:spLocks noGrp="1"/>
           </p:cNvSpPr>
@@ -4275,7 +4361,7 @@
       </p:grpSpPr>
       <p:sp>
         <p:nvSpPr>
-          <p:cNvPr id="491150620" name="Date Placeholder 1"/>
+          <p:cNvPr id="1336039961" name="Date Placeholder 1"/>
           <p:cNvSpPr>
             <a:spLocks noGrp="1"/>
           </p:cNvSpPr>
@@ -4301,7 +4387,7 @@
       </p:sp>
       <p:sp>
         <p:nvSpPr>
-          <p:cNvPr id="712210464" name="Footer Placeholder 2"/>
+          <p:cNvPr id="1356503038" name="Footer Placeholder 2"/>
           <p:cNvSpPr>
             <a:spLocks noGrp="1"/>
           </p:cNvSpPr>
@@ -4323,7 +4409,7 @@
       </p:sp>
       <p:sp>
         <p:nvSpPr>
-          <p:cNvPr id="1918795294" name="Slide Number Placeholder 3"/>
+          <p:cNvPr id="574490611" name="Slide Number Placeholder 3"/>
           <p:cNvSpPr>
             <a:spLocks noGrp="1"/>
           </p:cNvSpPr>
@@ -4374,7 +4460,7 @@
       </p:grpSpPr>
       <p:sp>
         <p:nvSpPr>
-          <p:cNvPr id="790876312" name="Title 1"/>
+          <p:cNvPr id="329590273" name="Title 1"/>
           <p:cNvSpPr>
             <a:spLocks noGrp="1"/>
           </p:cNvSpPr>
@@ -4409,7 +4495,7 @@
       </p:sp>
       <p:sp>
         <p:nvSpPr>
-          <p:cNvPr id="45141126" name="Content Placeholder 2"/>
+          <p:cNvPr id="981142677" name="Content Placeholder 2"/>
           <p:cNvSpPr>
             <a:spLocks noGrp="1"/>
           </p:cNvSpPr>
@@ -4508,7 +4594,7 @@
       </p:sp>
       <p:sp>
         <p:nvSpPr>
-          <p:cNvPr id="1721953406" name="Text Placeholder 3"/>
+          <p:cNvPr id="1617040772" name="Text Placeholder 3"/>
           <p:cNvSpPr>
             <a:spLocks noGrp="1"/>
           </p:cNvSpPr>
@@ -4576,7 +4662,7 @@
       </p:sp>
       <p:sp>
         <p:nvSpPr>
-          <p:cNvPr id="253255573" name="Date Placeholder 4"/>
+          <p:cNvPr id="436254716" name="Date Placeholder 4"/>
           <p:cNvSpPr>
             <a:spLocks noGrp="1"/>
           </p:cNvSpPr>
@@ -4602,7 +4688,7 @@
       </p:sp>
       <p:sp>
         <p:nvSpPr>
-          <p:cNvPr id="834163214" name="Footer Placeholder 5"/>
+          <p:cNvPr id="1769777207" name="Footer Placeholder 5"/>
           <p:cNvSpPr>
             <a:spLocks noGrp="1"/>
           </p:cNvSpPr>
@@ -4624,7 +4710,7 @@
       </p:sp>
       <p:sp>
         <p:nvSpPr>
-          <p:cNvPr id="1468863789" name="Slide Number Placeholder 6"/>
+          <p:cNvPr id="355760252" name="Slide Number Placeholder 6"/>
           <p:cNvSpPr>
             <a:spLocks noGrp="1"/>
           </p:cNvSpPr>
@@ -4675,7 +4761,7 @@
       </p:grpSpPr>
       <p:sp>
         <p:nvSpPr>
-          <p:cNvPr id="1654427545" name="Title 1"/>
+          <p:cNvPr id="421880649" name="Title 1"/>
           <p:cNvSpPr>
             <a:spLocks noGrp="1"/>
           </p:cNvSpPr>
@@ -4710,7 +4796,7 @@
       </p:sp>
       <p:sp>
         <p:nvSpPr>
-          <p:cNvPr id="1717588427" name="Picture Placeholder 2"/>
+          <p:cNvPr id="6746709" name="Picture Placeholder 2"/>
           <p:cNvSpPr>
             <a:spLocks noGrp="1"/>
           </p:cNvSpPr>
@@ -4774,7 +4860,7 @@
       </p:sp>
       <p:sp>
         <p:nvSpPr>
-          <p:cNvPr id="14017183" name="Text Placeholder 3"/>
+          <p:cNvPr id="1048332805" name="Text Placeholder 3"/>
           <p:cNvSpPr>
             <a:spLocks noGrp="1"/>
           </p:cNvSpPr>
@@ -4842,7 +4928,7 @@
       </p:sp>
       <p:sp>
         <p:nvSpPr>
-          <p:cNvPr id="187707211" name="Date Placeholder 4"/>
+          <p:cNvPr id="1308198933" name="Date Placeholder 4"/>
           <p:cNvSpPr>
             <a:spLocks noGrp="1"/>
           </p:cNvSpPr>
@@ -4868,7 +4954,7 @@
       </p:sp>
       <p:sp>
         <p:nvSpPr>
-          <p:cNvPr id="281273495" name="Footer Placeholder 5"/>
+          <p:cNvPr id="450018452" name="Footer Placeholder 5"/>
           <p:cNvSpPr>
             <a:spLocks noGrp="1"/>
           </p:cNvSpPr>
@@ -4890,7 +4976,7 @@
       </p:sp>
       <p:sp>
         <p:nvSpPr>
-          <p:cNvPr id="119922739" name="Slide Number Placeholder 6"/>
+          <p:cNvPr id="1082601293" name="Slide Number Placeholder 6"/>
           <p:cNvSpPr>
             <a:spLocks noGrp="1"/>
           </p:cNvSpPr>
@@ -4946,7 +5032,7 @@
       </p:grpSpPr>
       <p:sp>
         <p:nvSpPr>
-          <p:cNvPr id="1297158661" name="Shape 1059"/>
+          <p:cNvPr id="1227428129" name="Shape 1059"/>
           <p:cNvSpPr>
             <a:spLocks noChangeArrowheads="1" noGrp="1"/>
           </p:cNvSpPr>
@@ -5024,7 +5110,7 @@
       </p:sp>
       <p:sp>
         <p:nvSpPr>
-          <p:cNvPr id="1813546439" name="Shape 1060"/>
+          <p:cNvPr id="149734012" name="Shape 1060"/>
           <p:cNvSpPr>
             <a:spLocks noChangeArrowheads="1" noGrp="1"/>
           </p:cNvSpPr>
@@ -5105,7 +5191,7 @@
       </p:sp>
       <p:sp>
         <p:nvSpPr>
-          <p:cNvPr id="447478855" name="Shape 1061"/>
+          <p:cNvPr id="308404353" name="Shape 1061"/>
           <p:cNvSpPr>
             <a:spLocks noChangeArrowheads="1" noGrp="1"/>
           </p:cNvSpPr>
@@ -5223,7 +5309,7 @@
       </p:sp>
       <p:sp>
         <p:nvSpPr>
-          <p:cNvPr id="181512258" name="Title 1"/>
+          <p:cNvPr id="142460424" name="Title 1"/>
           <p:cNvSpPr>
             <a:spLocks noGrp="1"/>
           </p:cNvSpPr>
@@ -5259,7 +5345,7 @@
       </p:sp>
       <p:sp>
         <p:nvSpPr>
-          <p:cNvPr id="1029361065" name="Text Placeholder 2"/>
+          <p:cNvPr id="380180792" name="Text Placeholder 2"/>
           <p:cNvSpPr>
             <a:spLocks noGrp="1"/>
           </p:cNvSpPr>
@@ -5335,7 +5421,7 @@
       </p:sp>
       <p:sp>
         <p:nvSpPr>
-          <p:cNvPr id="390082827" name="Date Placeholder 3"/>
+          <p:cNvPr id="248743923" name="Date Placeholder 3"/>
           <p:cNvSpPr>
             <a:spLocks noGrp="1"/>
           </p:cNvSpPr>
@@ -5379,7 +5465,7 @@
       </p:sp>
       <p:sp>
         <p:nvSpPr>
-          <p:cNvPr id="296270035" name="Footer Placeholder 4"/>
+          <p:cNvPr id="349576576" name="Footer Placeholder 4"/>
           <p:cNvSpPr>
             <a:spLocks noGrp="1"/>
           </p:cNvSpPr>
@@ -5419,7 +5505,7 @@
       </p:sp>
       <p:sp>
         <p:nvSpPr>
-          <p:cNvPr id="897677434" name="Slide Number Placeholder 5"/>
+          <p:cNvPr id="1329519742" name="Slide Number Placeholder 5"/>
           <p:cNvSpPr>
             <a:spLocks noGrp="1"/>
           </p:cNvSpPr>
@@ -5767,7 +5853,7 @@
       </p:grpSpPr>
       <p:sp>
         <p:nvSpPr>
-          <p:cNvPr id="536430027" name="Title 1"/>
+          <p:cNvPr id="1020191493" name="Title 1"/>
           <p:cNvSpPr>
             <a:spLocks noGrp="1"/>
           </p:cNvSpPr>
@@ -5804,7 +5890,7 @@
       </p:sp>
       <p:sp>
         <p:nvSpPr>
-          <p:cNvPr id="1686235984" name=""/>
+          <p:cNvPr id="1331837338" name=""/>
           <p:cNvSpPr txBox="1"/>
           <p:nvPr/>
         </p:nvSpPr>
@@ -5876,7 +5962,7 @@
       </p:grpSpPr>
       <p:sp>
         <p:nvSpPr>
-          <p:cNvPr id="2119451194" name=""/>
+          <p:cNvPr id="458313037" name=""/>
           <p:cNvSpPr/>
           <p:nvPr/>
         </p:nvSpPr>
@@ -6055,7 +6141,7 @@
       </p:sp>
       <p:pic>
         <p:nvPicPr>
-          <p:cNvPr id="1839494160" name=""/>
+          <p:cNvPr id="1304114913" name=""/>
           <p:cNvPicPr>
             <a:picLocks noChangeAspect="1"/>
           </p:cNvPicPr>
@@ -6077,7 +6163,7 @@
       </p:pic>
       <p:graphicFrame>
         <p:nvGraphicFramePr>
-          <p:cNvPr id="580397129" name=""/>
+          <p:cNvPr id="156962748" name=""/>
           <p:cNvGraphicFramePr>
             <a:graphicFrameLocks xmlns:a="http://schemas.openxmlformats.org/drawingml/2006/main"/>
           </p:cNvGraphicFramePr>
@@ -6490,7 +6576,7 @@
       </p:grpSpPr>
       <p:sp>
         <p:nvSpPr>
-          <p:cNvPr id="2073389056" name="Title 1"/>
+          <p:cNvPr id="790046590" name="Title 1"/>
           <p:cNvSpPr>
             <a:spLocks noGrp="1"/>
           </p:cNvSpPr>
@@ -6516,7 +6602,7 @@
       </p:sp>
       <p:pic>
         <p:nvPicPr>
-          <p:cNvPr id="127551612" name=""/>
+          <p:cNvPr id="1201901506" name=""/>
           <p:cNvPicPr>
             <a:picLocks noChangeAspect="1"/>
           </p:cNvPicPr>
@@ -6539,7 +6625,7 @@
       </p:pic>
       <p:pic>
         <p:nvPicPr>
-          <p:cNvPr id="214109048" name=""/>
+          <p:cNvPr id="1100614917" name=""/>
           <p:cNvPicPr>
             <a:picLocks noChangeAspect="1"/>
           </p:cNvPicPr>
@@ -6562,7 +6648,7 @@
       </p:pic>
       <p:pic>
         <p:nvPicPr>
-          <p:cNvPr id="162626701" name=""/>
+          <p:cNvPr id="1790638122" name=""/>
           <p:cNvPicPr>
             <a:picLocks noChangeAspect="1"/>
           </p:cNvPicPr>
@@ -6585,7 +6671,7 @@
       </p:pic>
       <p:pic>
         <p:nvPicPr>
-          <p:cNvPr id="748633002" name=""/>
+          <p:cNvPr id="1836393648" name=""/>
           <p:cNvPicPr>
             <a:picLocks noChangeAspect="1"/>
           </p:cNvPicPr>
@@ -6641,7 +6727,7 @@
       </p:grpSpPr>
       <p:sp>
         <p:nvSpPr>
-          <p:cNvPr id="19869371" name="Title 1"/>
+          <p:cNvPr id="8258835" name="Title 1"/>
           <p:cNvSpPr>
             <a:spLocks noGrp="1"/>
           </p:cNvSpPr>
@@ -6667,7 +6753,7 @@
       </p:sp>
       <p:sp>
         <p:nvSpPr>
-          <p:cNvPr id="728043803" name="Content Placeholder 2"/>
+          <p:cNvPr id="1077949908" name="Content Placeholder 2"/>
           <p:cNvSpPr>
             <a:spLocks noGrp="1"/>
           </p:cNvSpPr>
@@ -6768,7 +6854,7 @@
       </p:grpSpPr>
       <p:sp>
         <p:nvSpPr>
-          <p:cNvPr id="402664114" name="Title 1"/>
+          <p:cNvPr id="32523635" name="Title 1"/>
           <p:cNvSpPr>
             <a:spLocks noGrp="1"/>
           </p:cNvSpPr>
@@ -6790,7 +6876,7 @@
       </p:sp>
       <p:sp>
         <p:nvSpPr>
-          <p:cNvPr id="336562242" name="Content Placeholder 2"/>
+          <p:cNvPr id="1812541438" name="Content Placeholder 2"/>
           <p:cNvSpPr>
             <a:spLocks noGrp="1"/>
           </p:cNvSpPr>
@@ -6851,7 +6937,7 @@
       </p:grpSpPr>
       <p:sp>
         <p:nvSpPr>
-          <p:cNvPr id="1438765731" name="Title 1"/>
+          <p:cNvPr id="1635434063" name="Title 1"/>
           <p:cNvSpPr>
             <a:spLocks noGrp="1"/>
           </p:cNvSpPr>
@@ -6877,7 +6963,7 @@
       </p:sp>
       <p:sp>
         <p:nvSpPr>
-          <p:cNvPr id="1642235807" name="Content Placeholder 2"/>
+          <p:cNvPr id="629853732" name="Content Placeholder 2"/>
           <p:cNvSpPr>
             <a:spLocks noGrp="1"/>
           </p:cNvSpPr>
@@ -7036,7 +7122,7 @@
       </p:grpSpPr>
       <p:sp>
         <p:nvSpPr>
-          <p:cNvPr id="1393597879" name="Title 1"/>
+          <p:cNvPr id="899171511" name="Title 1"/>
           <p:cNvSpPr>
             <a:spLocks noGrp="1"/>
           </p:cNvSpPr>
@@ -7062,7 +7148,7 @@
       </p:sp>
       <p:sp>
         <p:nvSpPr>
-          <p:cNvPr id="1773193123" name="Content Placeholder 2"/>
+          <p:cNvPr id="191768430" name="Content Placeholder 2"/>
           <p:cNvSpPr>
             <a:spLocks noGrp="1"/>
           </p:cNvSpPr>
@@ -7109,6 +7195,112 @@
               <a:t>Potensi atau komitmen diteruskan untuk penelitian lebih lanjut</a:t>
             </a:r>
             <a:endParaRPr sz="2800" i="0"/>
+          </a:p>
+          <a:p>
+            <a:pPr>
+              <a:defRPr/>
+            </a:pPr>
+            <a:endParaRPr sz="2800"/>
+          </a:p>
+        </p:txBody>
+      </p:sp>
+    </p:spTree>
+  </p:cSld>
+  <p:clrMapOvr>
+    <a:masterClrMapping/>
+  </p:clrMapOvr>
+  <mc:AlternateContent xmlns:mc="http://schemas.openxmlformats.org/markup-compatibility/2006">
+    <mc:Choice xmlns:p159="http://schemas.microsoft.com/office/powerpoint/2015/09/main" xmlns:p14="http://schemas.microsoft.com/office/powerpoint/2010/main" Requires="p159">
+      <p:transition p14:dur="2000" advClick="1"/>
+    </mc:Choice>
+    <mc:Fallback>
+      <p:transition advClick="1"/>
+    </mc:Fallback>
+  </mc:AlternateContent>
+</p:sld>
+</file>
+
+<file path=ppt/slides/slide16.xml><?xml version="1.0" encoding="utf-8"?>
+<p:sld xmlns:a="http://schemas.openxmlformats.org/drawingml/2006/main" xmlns:r="http://schemas.openxmlformats.org/officeDocument/2006/relationships" xmlns:p="http://schemas.openxmlformats.org/presentationml/2006/main" xmlns:m="http://schemas.openxmlformats.org/officeDocument/2006/math" xmlns:w="http://schemas.openxmlformats.org/wordprocessingml/2006/main" xmlns:mc="http://schemas.openxmlformats.org/markup-compatibility/2006" showMasterPhAnim="0" showMasterSp="1" show="1">
+  <p:cSld name="">
+    <p:spTree>
+      <p:nvGrpSpPr>
+        <p:cNvPr id="1" name=""/>
+        <p:cNvGrpSpPr/>
+        <p:nvPr/>
+      </p:nvGrpSpPr>
+      <p:grpSpPr bwMode="auto">
+        <a:xfrm>
+          <a:off x="0" y="0"/>
+          <a:ext cx="0" cy="0"/>
+          <a:chOff x="0" y="0"/>
+          <a:chExt cx="0" cy="0"/>
+        </a:xfrm>
+      </p:grpSpPr>
+      <p:sp>
+        <p:nvSpPr>
+          <p:cNvPr id="1499477582" name="Title 1"/>
+          <p:cNvSpPr>
+            <a:spLocks noGrp="1"/>
+          </p:cNvSpPr>
+          <p:nvPr>
+            <p:ph type="title"/>
+          </p:nvPr>
+        </p:nvSpPr>
+        <p:spPr bwMode="auto">
+          <a:xfrm>
+            <a:off x="609598" y="328299"/>
+            <a:ext cx="10972800" cy="1143000"/>
+          </a:xfrm>
+        </p:spPr>
+        <p:txBody>
+          <a:bodyPr/>
+          <a:lstStyle/>
+          <a:p>
+            <a:pPr>
+              <a:defRPr/>
+            </a:pPr>
+            <a:r>
+              <a:rPr/>
+              <a:t>Yang dikumpulkan:</a:t>
+            </a:r>
+            <a:endParaRPr/>
+          </a:p>
+        </p:txBody>
+      </p:sp>
+      <p:sp>
+        <p:nvSpPr>
+          <p:cNvPr id="209471467" name="Content Placeholder 2"/>
+          <p:cNvSpPr>
+            <a:spLocks noGrp="1"/>
+          </p:cNvSpPr>
+          <p:nvPr>
+            <p:ph idx="1"/>
+          </p:nvPr>
+        </p:nvSpPr>
+        <p:spPr bwMode="auto"/>
+        <p:txBody>
+          <a:bodyPr/>
+          <a:lstStyle/>
+          <a:p>
+            <a:pPr>
+              <a:defRPr/>
+            </a:pPr>
+            <a:r>
+              <a:rPr sz="2800" b="0"/>
+              <a:t>URL repository github</a:t>
+            </a:r>
+            <a:endParaRPr sz="2800" b="0"/>
+          </a:p>
+          <a:p>
+            <a:pPr>
+              <a:defRPr/>
+            </a:pPr>
+            <a:r>
+              <a:rPr sz="2800" b="0"/>
+              <a:t>Slide presentasi (PDF) disertakan dalam repository</a:t>
+            </a:r>
+            <a:endParaRPr sz="2800" b="0" i="1"/>
           </a:p>
           <a:p>
             <a:pPr>
@@ -7153,7 +7345,7 @@
       </p:grpSpPr>
       <p:pic>
         <p:nvPicPr>
-          <p:cNvPr id="60093168" name=""/>
+          <p:cNvPr id="752238933" name=""/>
           <p:cNvPicPr>
             <a:picLocks noChangeAspect="1"/>
           </p:cNvPicPr>
@@ -7208,7 +7400,7 @@
       </p:grpSpPr>
       <p:pic>
         <p:nvPicPr>
-          <p:cNvPr id="418940587" name=""/>
+          <p:cNvPr id="1237828504" name=""/>
           <p:cNvPicPr>
             <a:picLocks noChangeAspect="1"/>
           </p:cNvPicPr>
@@ -7230,7 +7422,7 @@
       </p:pic>
       <p:sp>
         <p:nvSpPr>
-          <p:cNvPr id="1870053658" name=""/>
+          <p:cNvPr id="240307791" name=""/>
           <p:cNvSpPr txBox="1"/>
           <p:nvPr/>
         </p:nvSpPr>
@@ -7268,7 +7460,7 @@
       </p:sp>
       <p:sp>
         <p:nvSpPr>
-          <p:cNvPr id="1547383840" name="Title 1"/>
+          <p:cNvPr id="1064758890" name="Title 1"/>
           <p:cNvSpPr>
             <a:spLocks noGrp="1"/>
           </p:cNvSpPr>
@@ -7332,7 +7524,7 @@
       </p:grpSpPr>
       <p:sp>
         <p:nvSpPr>
-          <p:cNvPr id="746354420" name="Title 1"/>
+          <p:cNvPr id="692765833" name="Title 1"/>
           <p:cNvSpPr>
             <a:spLocks noGrp="1"/>
           </p:cNvSpPr>
@@ -7358,7 +7550,7 @@
       </p:sp>
       <p:pic>
         <p:nvPicPr>
-          <p:cNvPr id="796339020" name=""/>
+          <p:cNvPr id="1087269367" name=""/>
           <p:cNvPicPr>
             <a:picLocks noChangeAspect="1"/>
           </p:cNvPicPr>
@@ -7380,7 +7572,7 @@
       </p:pic>
       <p:sp>
         <p:nvSpPr>
-          <p:cNvPr id="1920557783" name=""/>
+          <p:cNvPr id="546289677" name=""/>
           <p:cNvSpPr txBox="1"/>
           <p:nvPr/>
         </p:nvSpPr>
@@ -7451,7 +7643,7 @@
       </p:grpSpPr>
       <p:sp>
         <p:nvSpPr>
-          <p:cNvPr id="1851306343" name="Title 1"/>
+          <p:cNvPr id="913900528" name="Title 1"/>
           <p:cNvSpPr>
             <a:spLocks noGrp="1"/>
           </p:cNvSpPr>
@@ -7477,7 +7669,7 @@
       </p:sp>
       <p:pic>
         <p:nvPicPr>
-          <p:cNvPr id="518263436" name=""/>
+          <p:cNvPr id="351287581" name=""/>
           <p:cNvPicPr>
             <a:picLocks noChangeAspect="1"/>
           </p:cNvPicPr>
@@ -7491,7 +7683,7 @@
         <p:spPr bwMode="auto">
           <a:xfrm flipH="0" flipV="0">
             <a:off x="878415" y="1335681"/>
-            <a:ext cx="9249772" cy="5130586"/>
+            <a:ext cx="9249771" cy="5130586"/>
           </a:xfrm>
           <a:prstGeom prst="rect">
             <a:avLst/>
@@ -7500,7 +7692,7 @@
       </p:pic>
       <p:sp>
         <p:nvSpPr>
-          <p:cNvPr id="161043701" name=""/>
+          <p:cNvPr id="1386599234" name=""/>
           <p:cNvSpPr txBox="1"/>
           <p:nvPr/>
         </p:nvSpPr>
@@ -7571,7 +7763,7 @@
       </p:grpSpPr>
       <p:sp>
         <p:nvSpPr>
-          <p:cNvPr id="263673774" name=""/>
+          <p:cNvPr id="511695458" name=""/>
           <p:cNvSpPr txBox="1"/>
           <p:nvPr/>
         </p:nvSpPr>
@@ -7603,7 +7795,7 @@
       </p:sp>
       <p:pic>
         <p:nvPicPr>
-          <p:cNvPr id="1886893406" name=""/>
+          <p:cNvPr id="645707474" name=""/>
           <p:cNvPicPr>
             <a:picLocks noChangeAspect="1"/>
           </p:cNvPicPr>
@@ -7625,7 +7817,7 @@
       </p:pic>
       <p:pic>
         <p:nvPicPr>
-          <p:cNvPr id="495073044" name=""/>
+          <p:cNvPr id="473844228" name=""/>
           <p:cNvPicPr>
             <a:picLocks noChangeAspect="1"/>
           </p:cNvPicPr>
@@ -7647,7 +7839,7 @@
       </p:pic>
       <p:sp>
         <p:nvSpPr>
-          <p:cNvPr id="1522696822" name=""/>
+          <p:cNvPr id="234180915" name=""/>
           <p:cNvSpPr txBox="1"/>
           <p:nvPr/>
         </p:nvSpPr>
@@ -7705,7 +7897,7 @@
       </p:sp>
       <p:pic>
         <p:nvPicPr>
-          <p:cNvPr id="53250616" name=""/>
+          <p:cNvPr id="1178926912" name=""/>
           <p:cNvPicPr>
             <a:picLocks noChangeAspect="1"/>
           </p:cNvPicPr>
@@ -7727,7 +7919,7 @@
       </p:pic>
       <p:pic>
         <p:nvPicPr>
-          <p:cNvPr id="1805711074" name=""/>
+          <p:cNvPr id="2136552826" name=""/>
           <p:cNvPicPr>
             <a:picLocks noChangeAspect="1"/>
           </p:cNvPicPr>
@@ -7749,7 +7941,7 @@
       </p:pic>
       <p:pic>
         <p:nvPicPr>
-          <p:cNvPr id="2046952347" name=""/>
+          <p:cNvPr id="946783030" name=""/>
           <p:cNvPicPr>
             <a:picLocks noChangeAspect="1"/>
           </p:cNvPicPr>
@@ -7804,7 +7996,7 @@
       </p:grpSpPr>
       <p:pic>
         <p:nvPicPr>
-          <p:cNvPr id="709266133" name=""/>
+          <p:cNvPr id="1618834391" name=""/>
           <p:cNvPicPr>
             <a:picLocks noChangeAspect="1"/>
           </p:cNvPicPr>
@@ -7826,7 +8018,7 @@
       </p:pic>
       <p:sp>
         <p:nvSpPr>
-          <p:cNvPr id="922535843" name="Title 1"/>
+          <p:cNvPr id="699802637" name="Title 1"/>
           <p:cNvSpPr>
             <a:spLocks noGrp="1"/>
           </p:cNvSpPr>
@@ -7852,7 +8044,7 @@
       </p:sp>
       <p:sp>
         <p:nvSpPr>
-          <p:cNvPr id="1911961276" name=""/>
+          <p:cNvPr id="2078796187" name=""/>
           <p:cNvSpPr txBox="1"/>
           <p:nvPr/>
         </p:nvSpPr>
@@ -7917,7 +8109,7 @@
       </p:grpSpPr>
       <p:pic>
         <p:nvPicPr>
-          <p:cNvPr id="150288490" name=""/>
+          <p:cNvPr id="1103784009" name=""/>
           <p:cNvPicPr>
             <a:picLocks noChangeAspect="1"/>
           </p:cNvPicPr>
@@ -7939,7 +8131,7 @@
       </p:pic>
       <p:sp>
         <p:nvSpPr>
-          <p:cNvPr id="248511195" name="Title 1"/>
+          <p:cNvPr id="1853746426" name="Title 1"/>
           <p:cNvSpPr>
             <a:spLocks noGrp="1"/>
           </p:cNvSpPr>
@@ -7998,7 +8190,7 @@
       </p:grpSpPr>
       <p:sp>
         <p:nvSpPr>
-          <p:cNvPr id="767666965" name="Title 1"/>
+          <p:cNvPr id="25464158" name="Title 1"/>
           <p:cNvSpPr>
             <a:spLocks noGrp="1"/>
           </p:cNvSpPr>
@@ -8029,7 +8221,7 @@
       </p:sp>
       <p:pic>
         <p:nvPicPr>
-          <p:cNvPr id="1717301374" name=""/>
+          <p:cNvPr id="1303732237" name=""/>
           <p:cNvPicPr>
             <a:picLocks noChangeAspect="1"/>
           </p:cNvPicPr>
@@ -8052,7 +8244,7 @@
       </p:pic>
       <p:sp>
         <p:nvSpPr>
-          <p:cNvPr id="1223682576" name=""/>
+          <p:cNvPr id="1675301872" name=""/>
           <p:cNvSpPr txBox="1"/>
           <p:nvPr/>
         </p:nvSpPr>
@@ -8100,7 +8292,7 @@
       </p:sp>
       <p:sp>
         <p:nvSpPr>
-          <p:cNvPr id="1828014089" name=""/>
+          <p:cNvPr id="201848963" name=""/>
           <p:cNvSpPr/>
           <p:nvPr/>
         </p:nvSpPr>

</xml_diff>